<commit_message>
Update frontend, docs, assets, and config files
</commit_message>
<xml_diff>
--- a/docs/05_presentation/Chaukas_iQOO_Hackathon_2026.pptx
+++ b/docs/05_presentation/Chaukas_iQOO_Hackathon_2026.pptx
@@ -217,7 +217,7 @@
               <c:strCache>
                 <c:ptCount val="1"/>
                 <c:pt idx="0">
-                  <c:v>With Kirana Rakshak (target)</c:v>
+                  <c:v>With Chaukas (target)</c:v>
                 </c:pt>
               </c:strCache>
             </c:strRef>
@@ -832,7 +832,7 @@
           <a:p>
             <a:r>
               <a:rPr lang="en-US" dirty="0"/>
-              <a:t>Kirana Rakshak by Team HoloTrio for the iQOO Hackathon 2026 Grand Finale, Bengaluru. Primary track: Productivity; technical anchor: Open Innovation (local models, zero cloud).</a:t>
+              <a:t>Chaukas by Team HoloTrio for the iQOO Hackathon 2026 Grand Finale, Bengaluru. Primary track: Productivity; technical anchor: Open Innovation (local models, zero cloud).</a:t>
             </a:r>
             <a:endParaRPr lang="en-US" dirty="0"/>
           </a:p>
@@ -2263,7 +2263,7 @@
       </p:grpSpPr>
       <p:pic>
         <p:nvPicPr>
-          <p:cNvPr id="2" name="Image 0" descr="C:\Users\sansk\AppData\Local\Temp\claude\D--Projects-KiranaRakshak\0b423f22-21fc-4787-82d2-a3959a20cc81\scratchpad\img\hk_mark_white.png">    </p:cNvPr>
+          <p:cNvPr id="2" name="Image 0" descr="hk_mark_white.png">    </p:cNvPr>
           <p:cNvPicPr>
             <a:picLocks noChangeAspect="1"/>
           </p:cNvPicPr>
@@ -2383,7 +2383,7 @@
       </p:sp>
       <p:pic>
         <p:nvPicPr>
-          <p:cNvPr id="5" name="Image 1" descr="C:\Users\sansk\AppData\Local\Temp\claude\D--Projects-KiranaRakshak\0b423f22-21fc-4787-82d2-a3959a20cc81\scratchpad\img\app_icon.png">    </p:cNvPr>
+          <p:cNvPr id="5" name="Image 1" descr="app_icon.png">    </p:cNvPr>
           <p:cNvPicPr>
             <a:picLocks noChangeAspect="1"/>
           </p:cNvPicPr>
@@ -2413,73 +2413,34 @@
         </p:nvSpPr>
         <p:spPr>
           <a:xfrm>
-            <a:off x="548640" y="2926080"/>
-            <a:ext cx="6858000" cy="868680"/>
-          </a:xfrm>
-          <a:prstGeom prst="rect">
-            <a:avLst/>
-          </a:prstGeom>
-          <a:noFill/>
-          <a:ln/>
-        </p:spPr>
-        <p:txBody>
-          <a:bodyPr wrap="square" lIns="0" tIns="0" rIns="0" bIns="0" rtlCol="0" anchor="ctr"/>
-          <a:lstStyle/>
-          <a:p>
-            <a:pPr indent="0" marL="0">
-              <a:buNone/>
-            </a:pPr>
-            <a:r>
-              <a:rPr lang="en-US" sz="6000" dirty="0">
-                <a:solidFill>
-                  <a:srgbClr val="FFFFFF"/>
+            <a:off x="548640" y="3063240"/>
+            <a:ext cx="6858000" cy="1234440"/>
+          </a:xfrm>
+          <a:prstGeom prst="rect">
+            <a:avLst/>
+          </a:prstGeom>
+          <a:noFill/>
+          <a:ln/>
+        </p:spPr>
+        <p:txBody>
+          <a:bodyPr wrap="square" lIns="0" tIns="0" rIns="0" bIns="0" rtlCol="0" anchor="ctr"/>
+          <a:lstStyle/>
+          <a:p>
+            <a:pPr indent="0" marL="0">
+              <a:buNone/>
+            </a:pPr>
+            <a:r>
+              <a:rPr lang="en-US" sz="7200" dirty="0">
+                <a:solidFill>
+                  <a:srgbClr val="D4F639"/>
                 </a:solidFill>
                 <a:latin typeface="Arial Black" pitchFamily="34" charset="0"/>
                 <a:ea typeface="Arial Black" pitchFamily="34" charset="-122"/>
                 <a:cs typeface="Arial Black" pitchFamily="34" charset="-120"/>
               </a:rPr>
-              <a:t>KIRANA</a:t>
-            </a:r>
-            <a:endParaRPr lang="en-US" sz="6000" dirty="0"/>
-          </a:p>
-        </p:txBody>
-      </p:sp>
-      <p:sp>
-        <p:nvSpPr>
-          <p:cNvPr id="7" name="Text 3"/>
-          <p:cNvSpPr txBox="1"/>
-          <p:nvPr/>
-        </p:nvSpPr>
-        <p:spPr>
-          <a:xfrm>
-            <a:off x="548640" y="3703320"/>
-            <a:ext cx="6858000" cy="868680"/>
-          </a:xfrm>
-          <a:prstGeom prst="rect">
-            <a:avLst/>
-          </a:prstGeom>
-          <a:noFill/>
-          <a:ln/>
-        </p:spPr>
-        <p:txBody>
-          <a:bodyPr wrap="square" lIns="0" tIns="0" rIns="0" bIns="0" rtlCol="0" anchor="ctr"/>
-          <a:lstStyle/>
-          <a:p>
-            <a:pPr indent="0" marL="0">
-              <a:buNone/>
-            </a:pPr>
-            <a:r>
-              <a:rPr lang="en-US" sz="6000" dirty="0">
-                <a:solidFill>
-                  <a:srgbClr val="D4F639"/>
-                </a:solidFill>
-                <a:latin typeface="Arial Black" pitchFamily="34" charset="0"/>
-                <a:ea typeface="Arial Black" pitchFamily="34" charset="-122"/>
-                <a:cs typeface="Arial Black" pitchFamily="34" charset="-120"/>
-              </a:rPr>
-              <a:t>RAKSHAK</a:t>
-            </a:r>
-            <a:endParaRPr lang="en-US" sz="6000" dirty="0"/>
+              <a:t>CHAUKAS</a:t>
+            </a:r>
+            <a:endParaRPr lang="en-US" sz="7200" dirty="0"/>
           </a:p>
         </p:txBody>
       </p:sp>
@@ -2516,7 +2477,7 @@
                 <a:ea typeface="Arial" pitchFamily="34" charset="-122"/>
                 <a:cs typeface="Arial" pitchFamily="34" charset="-120"/>
               </a:rPr>
-              <a:t>Offline AI loss-prevention for India's kirana stores — powered entirely by the iQOO 15.</a:t>
+              <a:t>Offline AI loss-prevention for India's shops, godowns and factory stores — powered entirely by the iQOO 15.</a:t>
             </a:r>
             <a:endParaRPr lang="en-US" sz="1600" dirty="0"/>
           </a:p>
@@ -2656,6 +2617,23 @@
                 <a:cs typeface="Arial" pitchFamily="34" charset="-120"/>
               </a:rPr>
               <a:t>Shambhavi Patil  ·  Member</a:t>
+            </a:r>
+            <a:endParaRPr lang="en-US" sz="1200" dirty="0"/>
+          </a:p>
+          <a:p>
+            <a:pPr indent="0" marL="0">
+              <a:buNone/>
+            </a:pPr>
+            <a:r>
+              <a:rPr lang="en-US" sz="1200" dirty="0">
+                <a:solidFill>
+                  <a:srgbClr val="ECEDE6"/>
+                </a:solidFill>
+                <a:latin typeface="Arial" pitchFamily="34" charset="0"/>
+                <a:ea typeface="Arial" pitchFamily="34" charset="-122"/>
+                <a:cs typeface="Arial" pitchFamily="34" charset="-120"/>
+              </a:rPr>
+              <a:t>Kanishka Salgude  ·  Member</a:t>
             </a:r>
             <a:endParaRPr lang="en-US" sz="1200" dirty="0"/>
           </a:p>
@@ -2721,7 +2699,7 @@
       </p:sp>
       <p:pic>
         <p:nvPicPr>
-          <p:cNvPr id="14" name="Image 2" descr="C:\Users\sansk\AppData\Local\Temp\claude\D--Projects-KiranaRakshak\0b423f22-21fc-4787-82d2-a3959a20cc81\scratchpad\img\vendor-bill.png">    </p:cNvPr>
+          <p:cNvPr id="14" name="Image 2" descr="vendor-bill.png">    </p:cNvPr>
           <p:cNvPicPr>
             <a:picLocks noChangeAspect="1"/>
           </p:cNvPicPr>
@@ -2752,7 +2730,7 @@
       </p:pic>
       <p:pic>
         <p:nvPicPr>
-          <p:cNvPr id="15" name="Image 3" descr="C:\Users\sansk\AppData\Local\Temp\claude\D--Projects-KiranaRakshak\0b423f22-21fc-4787-82d2-a3959a20cc81\scratchpad\img\home.png">    </p:cNvPr>
+          <p:cNvPr id="15" name="Image 3" descr="home.png">    </p:cNvPr>
           <p:cNvPicPr>
             <a:picLocks noChangeAspect="1"/>
           </p:cNvPicPr>
@@ -2947,7 +2925,7 @@
       </p:grpSpPr>
       <p:pic>
         <p:nvPicPr>
-          <p:cNvPr id="2" name="Image 0" descr="C:\Users\sansk\AppData\Local\Temp\claude\D--Projects-KiranaRakshak\0b423f22-21fc-4787-82d2-a3959a20cc81\scratchpad\img\iqoo_white.png">    </p:cNvPr>
+          <p:cNvPr id="2" name="Image 0" descr="iqoo_white.png">    </p:cNvPr>
           <p:cNvPicPr>
             <a:picLocks noChangeAspect="1"/>
           </p:cNvPicPr>
@@ -3002,7 +2980,7 @@
                 <a:ea typeface="Arial" pitchFamily="34" charset="-122"/>
                 <a:cs typeface="Arial" pitchFamily="34" charset="-120"/>
               </a:rPr>
-              <a:t>iQOO HACKATHON 2026  ·  TEAM HOLOTRIO  ·  KIRANA RAKSHAK</a:t>
+              <a:t>iQOO HACKATHON 2026  ·  TEAM HOLOTRIO  ·  CHAUKAS</a:t>
             </a:r>
             <a:endParaRPr lang="en-US" sz="900" dirty="0"/>
           </a:p>
@@ -4620,7 +4598,7 @@
       </p:grpSpPr>
       <p:pic>
         <p:nvPicPr>
-          <p:cNvPr id="2" name="Image 0" descr="C:\Users\sansk\AppData\Local\Temp\claude\D--Projects-KiranaRakshak\0b423f22-21fc-4787-82d2-a3959a20cc81\scratchpad\img\iqoo_black.png">    </p:cNvPr>
+          <p:cNvPr id="2" name="Image 0" descr="iqoo_black.png">    </p:cNvPr>
           <p:cNvPicPr>
             <a:picLocks noChangeAspect="1"/>
           </p:cNvPicPr>
@@ -4675,7 +4653,7 @@
                 <a:ea typeface="Arial" pitchFamily="34" charset="-122"/>
                 <a:cs typeface="Arial" pitchFamily="34" charset="-120"/>
               </a:rPr>
-              <a:t>iQOO HACKATHON 2026  ·  TEAM HOLOTRIO  ·  KIRANA RAKSHAK</a:t>
+              <a:t>iQOO HACKATHON 2026  ·  TEAM HOLOTRIO  ·  CHAUKAS</a:t>
             </a:r>
             <a:endParaRPr lang="en-US" sz="900" dirty="0"/>
           </a:p>
@@ -5346,7 +5324,7 @@
       </p:grpSpPr>
       <p:pic>
         <p:nvPicPr>
-          <p:cNvPr id="2" name="Image 0" descr="C:\Users\sansk\AppData\Local\Temp\claude\D--Projects-KiranaRakshak\0b423f22-21fc-4787-82d2-a3959a20cc81\scratchpad\img\iqoo_white.png">    </p:cNvPr>
+          <p:cNvPr id="2" name="Image 0" descr="iqoo_white.png">    </p:cNvPr>
           <p:cNvPicPr>
             <a:picLocks noChangeAspect="1"/>
           </p:cNvPicPr>
@@ -5401,7 +5379,7 @@
                 <a:ea typeface="Arial" pitchFamily="34" charset="-122"/>
                 <a:cs typeface="Arial" pitchFamily="34" charset="-120"/>
               </a:rPr>
-              <a:t>iQOO HACKATHON 2026  ·  TEAM HOLOTRIO  ·  KIRANA RAKSHAK</a:t>
+              <a:t>iQOO HACKATHON 2026  ·  TEAM HOLOTRIO  ·  CHAUKAS</a:t>
             </a:r>
             <a:endParaRPr lang="en-US" sz="900" dirty="0"/>
           </a:p>
@@ -6494,7 +6472,7 @@
       </p:sp>
       <p:pic>
         <p:nvPicPr>
-          <p:cNvPr id="3" name="Image 0" descr="C:\Users\sansk\AppData\Local\Temp\claude\D--Projects-KiranaRakshak\0b423f22-21fc-4787-82d2-a3959a20cc81\scratchpad\img\hk_mark_white.png">    </p:cNvPr>
+          <p:cNvPr id="3" name="Image 0" descr="hk_mark_white.png">    </p:cNvPr>
           <p:cNvPicPr>
             <a:picLocks noChangeAspect="1"/>
           </p:cNvPicPr>
@@ -6549,7 +6527,7 @@
                 <a:ea typeface="Arial" pitchFamily="34" charset="-122"/>
                 <a:cs typeface="Arial" pitchFamily="34" charset="-120"/>
               </a:rPr>
-              <a:t>KIRANA RAKSHAK</a:t>
+              <a:t>CHAUKAS</a:t>
             </a:r>
             <a:endParaRPr lang="en-US" sz="1400" dirty="0"/>
           </a:p>
@@ -6700,7 +6678,7 @@
                 <a:ea typeface="Arial" pitchFamily="34" charset="-122"/>
                 <a:cs typeface="Arial" pitchFamily="34" charset="-120"/>
               </a:rPr>
-              <a:t>Sanskar Tiwari (Leader)  ·  Shambhavi Patil</a:t>
+              <a:t>Sanskar Tiwari (Leader)  ·  Shambhavi Patil  ·  Kanishka Salgude</a:t>
             </a:r>
             <a:endParaRPr lang="en-US" sz="1300" dirty="0"/>
           </a:p>
@@ -6747,7 +6725,7 @@
       </p:sp>
       <p:pic>
         <p:nvPicPr>
-          <p:cNvPr id="9" name="Image 1" descr="C:\Users\sansk\AppData\Local\Temp\claude\D--Projects-KiranaRakshak\0b423f22-21fc-4787-82d2-a3959a20cc81\scratchpad\img\app_icon.png">    </p:cNvPr>
+          <p:cNvPr id="9" name="Image 1" descr="app_icon.png">    </p:cNvPr>
           <p:cNvPicPr>
             <a:picLocks noChangeAspect="1"/>
           </p:cNvPicPr>
@@ -6842,7 +6820,7 @@
       </p:grpSpPr>
       <p:pic>
         <p:nvPicPr>
-          <p:cNvPr id="2" name="Image 0" descr="C:\Users\sansk\AppData\Local\Temp\claude\D--Projects-KiranaRakshak\0b423f22-21fc-4787-82d2-a3959a20cc81\scratchpad\img\iqoo_white.png">    </p:cNvPr>
+          <p:cNvPr id="2" name="Image 0" descr="iqoo_white.png">    </p:cNvPr>
           <p:cNvPicPr>
             <a:picLocks noChangeAspect="1"/>
           </p:cNvPicPr>
@@ -6897,7 +6875,7 @@
                 <a:ea typeface="Arial" pitchFamily="34" charset="-122"/>
                 <a:cs typeface="Arial" pitchFamily="34" charset="-120"/>
               </a:rPr>
-              <a:t>iQOO HACKATHON 2026  ·  TEAM HOLOTRIO  ·  KIRANA RAKSHAK</a:t>
+              <a:t>iQOO HACKATHON 2026  ·  TEAM HOLOTRIO  ·  CHAUKAS</a:t>
             </a:r>
             <a:endParaRPr lang="en-US" sz="900" dirty="0"/>
           </a:p>
@@ -7014,7 +6992,7 @@
                 <a:ea typeface="Arial Black" pitchFamily="34" charset="-122"/>
                 <a:cs typeface="Arial Black" pitchFamily="34" charset="-120"/>
               </a:rPr>
-              <a:t>Kiranas bleed money every morning.</a:t>
+              <a:t>Stock leaks money every morning.</a:t>
             </a:r>
             <a:endParaRPr lang="en-US" sz="3400" dirty="0"/>
           </a:p>
@@ -7119,7 +7097,7 @@
                 <a:ea typeface="Arial Black" pitchFamily="34" charset="-122"/>
                 <a:cs typeface="Arial Black" pitchFamily="34" charset="-120"/>
               </a:rPr>
-              <a:t>12M+</a:t>
+              <a:t>63M+</a:t>
             </a:r>
             <a:endParaRPr lang="en-US" sz="3000" dirty="0"/>
           </a:p>
@@ -7158,7 +7136,7 @@
                 <a:ea typeface="Arial" pitchFamily="34" charset="-122"/>
                 <a:cs typeface="Arial" pitchFamily="34" charset="-120"/>
               </a:rPr>
-              <a:t>neighbourhood kirana stores in India</a:t>
+              <a:t>small businesses (MSMEs) in India</a:t>
             </a:r>
             <a:endParaRPr lang="en-US" sz="1200" dirty="0"/>
           </a:p>
@@ -7969,7 +7947,7 @@
       </p:grpSpPr>
       <p:pic>
         <p:nvPicPr>
-          <p:cNvPr id="2" name="Image 0" descr="C:\Users\sansk\AppData\Local\Temp\claude\D--Projects-KiranaRakshak\0b423f22-21fc-4787-82d2-a3959a20cc81\scratchpad\img\iqoo_white.png">    </p:cNvPr>
+          <p:cNvPr id="2" name="Image 0" descr="iqoo_white.png">    </p:cNvPr>
           <p:cNvPicPr>
             <a:picLocks noChangeAspect="1"/>
           </p:cNvPicPr>
@@ -8024,7 +8002,7 @@
                 <a:ea typeface="Arial" pitchFamily="34" charset="-122"/>
                 <a:cs typeface="Arial" pitchFamily="34" charset="-120"/>
               </a:rPr>
-              <a:t>iQOO HACKATHON 2026  ·  TEAM HOLOTRIO  ·  KIRANA RAKSHAK</a:t>
+              <a:t>iQOO HACKATHON 2026  ·  TEAM HOLOTRIO  ·  CHAUKAS</a:t>
             </a:r>
             <a:endParaRPr lang="en-US" sz="900" dirty="0"/>
           </a:p>
@@ -8961,7 +8939,7 @@
       </p:grpSpPr>
       <p:pic>
         <p:nvPicPr>
-          <p:cNvPr id="2" name="Image 0" descr="C:\Users\sansk\AppData\Local\Temp\claude\D--Projects-KiranaRakshak\0b423f22-21fc-4787-82d2-a3959a20cc81\scratchpad\img\iqoo_black.png">    </p:cNvPr>
+          <p:cNvPr id="2" name="Image 0" descr="iqoo_black.png">    </p:cNvPr>
           <p:cNvPicPr>
             <a:picLocks noChangeAspect="1"/>
           </p:cNvPicPr>
@@ -9016,7 +8994,7 @@
                 <a:ea typeface="Arial" pitchFamily="34" charset="-122"/>
                 <a:cs typeface="Arial" pitchFamily="34" charset="-120"/>
               </a:rPr>
-              <a:t>iQOO HACKATHON 2026  ·  TEAM HOLOTRIO  ·  KIRANA RAKSHAK</a:t>
+              <a:t>iQOO HACKATHON 2026  ·  TEAM HOLOTRIO  ·  CHAUKAS</a:t>
             </a:r>
             <a:endParaRPr lang="en-US" sz="900" dirty="0"/>
           </a:p>
@@ -9141,7 +9119,7 @@
       </p:sp>
       <p:pic>
         <p:nvPicPr>
-          <p:cNvPr id="7" name="Image 1" descr="C:\Users\sansk\AppData\Local\Temp\claude\D--Projects-KiranaRakshak\0b423f22-21fc-4787-82d2-a3959a20cc81\scratchpad\img\home.png">    </p:cNvPr>
+          <p:cNvPr id="7" name="Image 1" descr="home.png">    </p:cNvPr>
           <p:cNvPicPr>
             <a:picLocks noChangeAspect="1"/>
           </p:cNvPicPr>
@@ -9289,7 +9267,7 @@
       </p:sp>
       <p:pic>
         <p:nvPicPr>
-          <p:cNvPr id="11" name="Image 2" descr="C:\Users\sansk\AppData\Local\Temp\claude\D--Projects-KiranaRakshak\0b423f22-21fc-4787-82d2-a3959a20cc81\scratchpad\img\vendor-scan.png">    </p:cNvPr>
+          <p:cNvPr id="11" name="Image 2" descr="vendor-scan.png">    </p:cNvPr>
           <p:cNvPicPr>
             <a:picLocks noChangeAspect="1"/>
           </p:cNvPicPr>
@@ -9437,7 +9415,7 @@
       </p:sp>
       <p:pic>
         <p:nvPicPr>
-          <p:cNvPr id="15" name="Image 3" descr="C:\Users\sansk\AppData\Local\Temp\claude\D--Projects-KiranaRakshak\0b423f22-21fc-4787-82d2-a3959a20cc81\scratchpad\img\vendor-bill.png">    </p:cNvPr>
+          <p:cNvPr id="15" name="Image 3" descr="vendor-bill.png">    </p:cNvPr>
           <p:cNvPicPr>
             <a:picLocks noChangeAspect="1"/>
           </p:cNvPicPr>
@@ -9616,7 +9594,7 @@
                 <a:ea typeface="Arial" pitchFamily="34" charset="-122"/>
                 <a:cs typeface="Arial" pitchFamily="34" charset="-120"/>
               </a:rPr>
-              <a:t>Screens captured from prototype/kirana_rakshak_ui.html</a:t>
+              <a:t>Screens captured from prototype/chaukas_ui.html</a:t>
             </a:r>
             <a:endParaRPr lang="en-US" sz="1000" dirty="0"/>
           </a:p>
@@ -9656,7 +9634,7 @@
       </p:grpSpPr>
       <p:pic>
         <p:nvPicPr>
-          <p:cNvPr id="2" name="Image 0" descr="C:\Users\sansk\AppData\Local\Temp\claude\D--Projects-KiranaRakshak\0b423f22-21fc-4787-82d2-a3959a20cc81\scratchpad\img\iqoo_white.png">    </p:cNvPr>
+          <p:cNvPr id="2" name="Image 0" descr="iqoo_white.png">    </p:cNvPr>
           <p:cNvPicPr>
             <a:picLocks noChangeAspect="1"/>
           </p:cNvPicPr>
@@ -9711,7 +9689,7 @@
                 <a:ea typeface="Arial" pitchFamily="34" charset="-122"/>
                 <a:cs typeface="Arial" pitchFamily="34" charset="-120"/>
               </a:rPr>
-              <a:t>iQOO HACKATHON 2026  ·  TEAM HOLOTRIO  ·  KIRANA RAKSHAK</a:t>
+              <a:t>iQOO HACKATHON 2026  ·  TEAM HOLOTRIO  ·  CHAUKAS</a:t>
             </a:r>
             <a:endParaRPr lang="en-US" sz="900" dirty="0"/>
           </a:p>
@@ -9836,7 +9814,7 @@
       </p:sp>
       <p:pic>
         <p:nvPicPr>
-          <p:cNvPr id="7" name="Image 1" descr="C:\Users\sansk\AppData\Local\Temp\claude\D--Projects-KiranaRakshak\0b423f22-21fc-4787-82d2-a3959a20cc81\scratchpad\img\sell.png">    </p:cNvPr>
+          <p:cNvPr id="7" name="Image 1" descr="sell.png">    </p:cNvPr>
           <p:cNvPicPr>
             <a:picLocks noChangeAspect="1"/>
           </p:cNvPicPr>
@@ -9867,7 +9845,7 @@
       </p:pic>
       <p:pic>
         <p:nvPicPr>
-          <p:cNvPr id="8" name="Image 2" descr="C:\Users\sansk\AppData\Local\Temp\claude\D--Projects-KiranaRakshak\0b423f22-21fc-4787-82d2-a3959a20cc81\scratchpad\img\assistant.png">    </p:cNvPr>
+          <p:cNvPr id="8" name="Image 2" descr="assistant.png">    </p:cNvPr>
           <p:cNvPicPr>
             <a:picLocks noChangeAspect="1"/>
           </p:cNvPicPr>
@@ -10232,7 +10210,7 @@
                 <a:ea typeface="Arial" pitchFamily="34" charset="-122"/>
                 <a:cs typeface="Arial" pitchFamily="34" charset="-120"/>
               </a:rPr>
-              <a:t>Built-in Kirana Soundbox</a:t>
+              <a:t>Built-in Chaukas Soundbox</a:t>
             </a:r>
             <a:endParaRPr lang="en-US" sz="1400" dirty="0"/>
           </a:p>
@@ -10438,7 +10416,7 @@
       </p:grpSpPr>
       <p:pic>
         <p:nvPicPr>
-          <p:cNvPr id="2" name="Image 0" descr="C:\Users\sansk\AppData\Local\Temp\claude\D--Projects-KiranaRakshak\0b423f22-21fc-4787-82d2-a3959a20cc81\scratchpad\img\iqoo_white.png">    </p:cNvPr>
+          <p:cNvPr id="2" name="Image 0" descr="iqoo_white.png">    </p:cNvPr>
           <p:cNvPicPr>
             <a:picLocks noChangeAspect="1"/>
           </p:cNvPicPr>
@@ -10493,7 +10471,7 @@
                 <a:ea typeface="Arial" pitchFamily="34" charset="-122"/>
                 <a:cs typeface="Arial" pitchFamily="34" charset="-120"/>
               </a:rPr>
-              <a:t>iQOO HACKATHON 2026  ·  TEAM HOLOTRIO  ·  KIRANA RAKSHAK</a:t>
+              <a:t>iQOO HACKATHON 2026  ·  TEAM HOLOTRIO  ·  CHAUKAS</a:t>
             </a:r>
             <a:endParaRPr lang="en-US" sz="900" dirty="0"/>
           </a:p>
@@ -12251,7 +12229,7 @@
       </p:grpSpPr>
       <p:pic>
         <p:nvPicPr>
-          <p:cNvPr id="2" name="Image 0" descr="C:\Users\sansk\AppData\Local\Temp\claude\D--Projects-KiranaRakshak\0b423f22-21fc-4787-82d2-a3959a20cc81\scratchpad\img\iqoo_black.png">    </p:cNvPr>
+          <p:cNvPr id="2" name="Image 0" descr="iqoo_black.png">    </p:cNvPr>
           <p:cNvPicPr>
             <a:picLocks noChangeAspect="1"/>
           </p:cNvPicPr>
@@ -12306,7 +12284,7 @@
                 <a:ea typeface="Arial" pitchFamily="34" charset="-122"/>
                 <a:cs typeface="Arial" pitchFamily="34" charset="-120"/>
               </a:rPr>
-              <a:t>iQOO HACKATHON 2026  ·  TEAM HOLOTRIO  ·  KIRANA RAKSHAK</a:t>
+              <a:t>iQOO HACKATHON 2026  ·  TEAM HOLOTRIO  ·  CHAUKAS</a:t>
             </a:r>
             <a:endParaRPr lang="en-US" sz="900" dirty="0"/>
           </a:p>
@@ -12431,7 +12409,7 @@
       </p:sp>
       <p:pic>
         <p:nvPicPr>
-          <p:cNvPr id="7" name="Image 1" descr="C:\Users\sansk\AppData\Local\Temp\claude\D--Projects-KiranaRakshak\0b423f22-21fc-4787-82d2-a3959a20cc81\scratchpad\img\iqoo_black.png">    </p:cNvPr>
+          <p:cNvPr id="7" name="Image 1" descr="iqoo_black.png">    </p:cNvPr>
           <p:cNvPicPr>
             <a:picLocks noChangeAspect="1"/>
           </p:cNvPicPr>
@@ -13999,7 +13977,7 @@
       </p:grpSpPr>
       <p:pic>
         <p:nvPicPr>
-          <p:cNvPr id="2" name="Image 0" descr="C:\Users\sansk\AppData\Local\Temp\claude\D--Projects-KiranaRakshak\0b423f22-21fc-4787-82d2-a3959a20cc81\scratchpad\img\iqoo_white.png">    </p:cNvPr>
+          <p:cNvPr id="2" name="Image 0" descr="iqoo_white.png">    </p:cNvPr>
           <p:cNvPicPr>
             <a:picLocks noChangeAspect="1"/>
           </p:cNvPicPr>
@@ -14054,7 +14032,7 @@
                 <a:ea typeface="Arial" pitchFamily="34" charset="-122"/>
                 <a:cs typeface="Arial" pitchFamily="34" charset="-120"/>
               </a:rPr>
-              <a:t>iQOO HACKATHON 2026  ·  TEAM HOLOTRIO  ·  KIRANA RAKSHAK</a:t>
+              <a:t>iQOO HACKATHON 2026  ·  TEAM HOLOTRIO  ·  CHAUKAS</a:t>
             </a:r>
             <a:endParaRPr lang="en-US" sz="900" dirty="0"/>
           </a:p>
@@ -15600,7 +15578,7 @@
       </p:grpSpPr>
       <p:pic>
         <p:nvPicPr>
-          <p:cNvPr id="2" name="Image 0" descr="C:\Users\sansk\AppData\Local\Temp\claude\D--Projects-KiranaRakshak\0b423f22-21fc-4787-82d2-a3959a20cc81\scratchpad\img\iqoo_white.png">    </p:cNvPr>
+          <p:cNvPr id="2" name="Image 0" descr="iqoo_white.png">    </p:cNvPr>
           <p:cNvPicPr>
             <a:picLocks noChangeAspect="1"/>
           </p:cNvPicPr>
@@ -15655,7 +15633,7 @@
                 <a:ea typeface="Arial" pitchFamily="34" charset="-122"/>
                 <a:cs typeface="Arial" pitchFamily="34" charset="-120"/>
               </a:rPr>
-              <a:t>iQOO HACKATHON 2026  ·  TEAM HOLOTRIO  ·  KIRANA RAKSHAK</a:t>
+              <a:t>iQOO HACKATHON 2026  ·  TEAM HOLOTRIO  ·  CHAUKAS</a:t>
             </a:r>
             <a:endParaRPr lang="en-US" sz="900" dirty="0"/>
           </a:p>

</xml_diff>